<commit_message>
fix: make security gates pass in GitHub
</commit_message>
<xml_diff>
--- a/arquitectura_devsecops_banca_corta_v7.pptx
+++ b/arquitectura_devsecops_banca_corta_v7.pptx
@@ -2,21 +2,21 @@
 <file path=ppt/presentation.xml><?xml version="1.0" encoding="utf-8"?>
 <p:presentation xmlns:p="http://schemas.openxmlformats.org/presentationml/2006/main">
   <p:sldMasterIdLst>
-    <p:sldMasterId xmlns:r="http://schemas.openxmlformats.org/officeDocument/2006/relationships" id="2147483648" r:id="Rd6ae4d5e3f69402a"/>
+    <p:sldMasterId xmlns:r="http://schemas.openxmlformats.org/officeDocument/2006/relationships" id="2147483648" r:id="R68a7fb56122241d6"/>
   </p:sldMasterIdLst>
   <p:notesMasterIdLst>
-    <p:notesMasterId xmlns:r="http://schemas.openxmlformats.org/officeDocument/2006/relationships" r:id="Rf1bb508e63cf44db"/>
+    <p:notesMasterId xmlns:r="http://schemas.openxmlformats.org/officeDocument/2006/relationships" r:id="Rc576c2fe7fa94f09"/>
   </p:notesMasterIdLst>
   <p:sldIdLst>
-    <p:sldId xmlns:r="http://schemas.openxmlformats.org/officeDocument/2006/relationships" id="256" r:id="Rc425a0dd4a5342f7"/>
-    <p:sldId xmlns:r="http://schemas.openxmlformats.org/officeDocument/2006/relationships" id="257" r:id="R7fd04890712e4efd"/>
-    <p:sldId xmlns:r="http://schemas.openxmlformats.org/officeDocument/2006/relationships" id="258" r:id="Rf8ecd214fb404304"/>
-    <p:sldId xmlns:r="http://schemas.openxmlformats.org/officeDocument/2006/relationships" id="259" r:id="R401279fd53ca4976"/>
-    <p:sldId xmlns:r="http://schemas.openxmlformats.org/officeDocument/2006/relationships" id="260" r:id="R52e0b47b9a2f45a0"/>
-    <p:sldId xmlns:r="http://schemas.openxmlformats.org/officeDocument/2006/relationships" id="261" r:id="R0d46fc3585b5469b"/>
-    <p:sldId xmlns:r="http://schemas.openxmlformats.org/officeDocument/2006/relationships" id="262" r:id="Rd12a4b628476452c"/>
-    <p:sldId xmlns:r="http://schemas.openxmlformats.org/officeDocument/2006/relationships" id="263" r:id="R2c05b46584224c71"/>
-    <p:sldId xmlns:r="http://schemas.openxmlformats.org/officeDocument/2006/relationships" id="264" r:id="R1d932c00fa794193"/>
+    <p:sldId xmlns:r="http://schemas.openxmlformats.org/officeDocument/2006/relationships" id="256" r:id="Raa2bd8edfc5b4103"/>
+    <p:sldId xmlns:r="http://schemas.openxmlformats.org/officeDocument/2006/relationships" id="257" r:id="R3dd0cde68b3b4e14"/>
+    <p:sldId xmlns:r="http://schemas.openxmlformats.org/officeDocument/2006/relationships" id="258" r:id="Rbc18f93bb3724d40"/>
+    <p:sldId xmlns:r="http://schemas.openxmlformats.org/officeDocument/2006/relationships" id="259" r:id="R56e257de006b45e8"/>
+    <p:sldId xmlns:r="http://schemas.openxmlformats.org/officeDocument/2006/relationships" id="260" r:id="Rfad0c7db58d444aa"/>
+    <p:sldId xmlns:r="http://schemas.openxmlformats.org/officeDocument/2006/relationships" id="261" r:id="R02de9160686d47f3"/>
+    <p:sldId xmlns:r="http://schemas.openxmlformats.org/officeDocument/2006/relationships" id="262" r:id="Rf5ee70f004564661"/>
+    <p:sldId xmlns:r="http://schemas.openxmlformats.org/officeDocument/2006/relationships" id="263" r:id="R2250cd693b394fb9"/>
+    <p:sldId xmlns:r="http://schemas.openxmlformats.org/officeDocument/2006/relationships" id="264" r:id="R091ee2c129af41c0"/>
   </p:sldIdLst>
   <p:sldSz cx="12192000" cy="6858000"/>
   <p:notesSz cx="6858000" cy="9144000"/>
@@ -1218,7 +1218,7 @@
   </p:cSld>
   <p:clrMap bg1="lt1" tx1="dk1" bg2="lt2" tx2="dk2" accent1="accent1" accent2="accent2" accent3="accent3" accent4="accent4" accent5="accent5" accent6="accent6" hlink="hlink" folHlink="folHlink"/>
   <p:sldLayoutIdLst>
-    <p:sldLayoutId xmlns:r="http://schemas.openxmlformats.org/officeDocument/2006/relationships" id="2147483649" r:id="R99d2e8dad2cf42b5"/>
+    <p:sldLayoutId xmlns:r="http://schemas.openxmlformats.org/officeDocument/2006/relationships" id="2147483649" r:id="Rb296f8cd3df94083"/>
   </p:sldLayoutIdLst>
   <p:hf sldNum="0" hdr="0" ftr="0" dt="0"/>
   <p:txStyles>
@@ -8092,7 +8092,7 @@
                   <a:srgbClr val="D9E8FF"/>
                 </a:solidFill>
               </a:rPr>
-              <a:t>Exige 10 checks y bloquea cambios que no cumplen.</a:t>
+              <a:t>Exige 11 gates de workflow y bloquea cambios que no cumplen.</a:t>
             </a:r>
           </a:p>
         </p:txBody>
@@ -8934,7 +8934,7 @@
                   <a:srgbClr val="FFFFFF"/>
                 </a:solidFill>
               </a:rPr>
-              <a:t>10 checks en verde</a:t>
+              <a:t>11 gates de workflow</a:t>
             </a:r>
           </a:p>
         </p:txBody>

</xml_diff>